<commit_message>
Add design-effect variance smoothing for MFH
Add an opt-in MFH smoothing mode that models design effects and rebuilds headcount variances using each domain’s rate and sample size. Validate the configuration, fall back to sample-size smoothing for unsupported indicators, and add coverage for smoothing behavior and edge cases.
</commit_message>
<xml_diff>
--- a/docs/instructions/English/EU_SAE_Workbench_Guide_2_Running_the_Workbench.pptx
+++ b/docs/instructions/English/EU_SAE_Workbench_Guide_2_Running_the_Workbench.pptx
@@ -648,7 +648,7 @@
           <a:p>
             <a:r>
               <a:rPr lang="en-US" dirty="0"/>
-              <a:t>Current defaults: UFH arcsin for FGT0 with its separate effective-sample-size variance; sm_all for no transformation or log mean welfare. The UFH variance selector is available and honored for log models. MFH defaults to sm_all and rho_sm_all, MFH2 and AIC. Explicit saved choices are retained. An omitted MFH covariance setting follows the effective variance choice. sm_out remains an optional sensitivity with its unchanged 0.001 cutoff on the modeled scale. These screenshots and 100-replicate results are historical w5o examples, not runs under the new defaults.</a:t>
+              <a:t>Current defaults: UFH arcsin for FGT0 with its separate effective-sample-size variance; sm_out for no transformation or log mean welfare. The UFH variance selector is available and honored for log models. MFH defaults to sm_out and rho_sm_out, MFH2 and AIC. Explicit saved choices are retained. An omitted MFH covariance setting follows the effective variance choice. sm_out keeps its 0.001 cutoff on the modeled scale. sm_all remains an option; because its GVF uses sample size only, it can overstate the variances of low-poverty areas (guidelines note, Section 6.6). These screenshots and 100-replicate results are historical w5o examples.</a:t>
             </a:r>
             <a:endParaRPr lang="en-US" dirty="0"/>
           </a:p>
@@ -3666,7 +3666,7 @@
                   <a:srgbClr val="33415C"/>
                 </a:solidFill>
               </a:rPr>
-              <a:t>MFH2, sm_all / rho_sm_all, 500 replicates. Explicit saved choices are retained.</a:t>
+              <a:t>MFH2, sm_out / rho_sm_out, 500 replicates. Explicit saved choices are retained.</a:t>
             </a:r>
             <a:endParaRPr lang="en-US" sz="1150" dirty="0"/>
           </a:p>

</xml_diff>

<commit_message>
Complete the PSU design rollout and draft the QER gate
Declare linked PSUs in the six Spain_2y configurations and the integration
test, which stopped at MFH after the explicit design choice was added. Warn
when a linked declaration finds no PSU, or no stratum and PSU pair, shared
across years, because the estimated covariance is then zero. Explain how to
run UFH alone when MFH is blocked.

Update the guides, method notes and changelog, and add a bridge receipt for
the changed configuration hashes. Add the draft release gate and the
"not specified" decision note. The Polish and Greek Guide 2 PDFs are not
regenerated and still show the earlier checkbox text.

Co-Authored-By: Claude Opus 5.5 <noreply@anthropic.com>
</commit_message>
<xml_diff>
--- a/docs/instructions/English/EU_SAE_Workbench_Guide_2_Running_the_Workbench.pptx
+++ b/docs/instructions/English/EU_SAE_Workbench_Guide_2_Running_the_Workbench.pptx
@@ -3702,7 +3702,7 @@
                   <a:srgbClr val="16233D"/>
                 </a:solidFill>
               </a:rPr>
-              <a:t>PSU codes consistent</a:t>
+              <a:t>Cross-year PSU design</a:t>
             </a:r>
             <a:endParaRPr lang="en-US" sz="1150" dirty="0"/>
           </a:p>
@@ -3716,7 +3716,7 @@
                   <a:srgbClr val="33415C"/>
                 </a:solidFill>
               </a:rPr>
-              <a:t>Under Data assessment: tick only if codes mean the same units in both years.</a:t>
+              <a:t>Choose from the survey design. MFH does not run while it is Not specified.</a:t>
             </a:r>
             <a:endParaRPr lang="en-US" sz="1150" dirty="0"/>
           </a:p>

</xml_diff>